<commit_message>
Update day 8 presentation
</commit_message>
<xml_diff>
--- a/заняття_8_django_orm_cbv/презентація/django_orm_lesson.pptx
+++ b/заняття_8_django_orm_cbv/презентація/django_orm_lesson.pptx
@@ -2359,7 +2359,7 @@
               <a:buNone/>
             </a:pPr>
             <a:r>
-              <a:rPr lang="en-US" sz="3400" dirty="0">
+              <a:rPr lang="en-US" sz="2400" dirty="0">
                 <a:solidFill>
                   <a:srgbClr val="FFFFFF"/>
                 </a:solidFill>
@@ -2367,9 +2367,20 @@
                 <a:ea typeface="Arial Black" pitchFamily="34" charset="-122"/>
                 <a:cs typeface="Arial Black" pitchFamily="34" charset="-120"/>
               </a:rPr>
-              <a:t>ORM, Шаблони та CBV</a:t>
-            </a:r>
-            <a:endParaRPr lang="en-US" sz="3400" dirty="0"/>
+              <a:t>ORM, Шаблони та </a:t>
+            </a:r>
+            <a:r>
+              <a:rPr lang="uk-UA" sz="2400" dirty="0">
+                <a:solidFill>
+                  <a:srgbClr val="FFFFFF"/>
+                </a:solidFill>
+                <a:latin typeface="Arial Black" pitchFamily="34" charset="0"/>
+                <a:ea typeface="Arial Black" pitchFamily="34" charset="-122"/>
+                <a:cs typeface="Arial Black" pitchFamily="34" charset="-120"/>
+              </a:rPr>
+              <a:t>звʼязки між моделями</a:t>
+            </a:r>
+            <a:endParaRPr lang="en-US" sz="2400" dirty="0"/>
           </a:p>
         </p:txBody>
       </p:sp>

</xml_diff>